<commit_message>
Auto commit -10-07-2026- 10:46:53
</commit_message>
<xml_diff>
--- a/docs/Pitch Deck/PlacementHub Pitch Deck.pptx
+++ b/docs/Pitch Deck/PlacementHub Pitch Deck.pptx
@@ -5,7 +5,7 @@
     <p:sldMasterId id="2147483648" r:id="rId1"/>
   </p:sldMasterIdLst>
   <p:notesMasterIdLst>
-    <p:notesMasterId r:id="rId12"/>
+    <p:notesMasterId r:id="rId13"/>
   </p:notesMasterIdLst>
   <p:sldIdLst>
     <p:sldId id="256" r:id="rId2"/>
@@ -18,17 +18,20 @@
     <p:sldId id="263" r:id="rId9"/>
     <p:sldId id="264" r:id="rId10"/>
     <p:sldId id="265" r:id="rId11"/>
+    <p:sldId id="266" r:id="rId12"/>
   </p:sldIdLst>
   <p:sldSz cx="16256000" cy="9144000"/>
   <p:notesSz cx="9144000" cy="16256000"/>
   <p:embeddedFontLst>
     <p:embeddedFont>
       <p:font typeface="Liter" panose="020B0604020202020204" charset="0"/>
-      <p:regular r:id="rId13"/>
+      <p:regular r:id="rId14"/>
     </p:embeddedFont>
     <p:embeddedFont>
       <p:font typeface="Quattrocento Sans" panose="020B0502050000020003" pitchFamily="34" charset="0"/>
-      <p:regular r:id="rId14"/>
+      <p:regular r:id="rId15"/>
+      <p:bold r:id="rId16"/>
+      <p:italic r:id="rId17"/>
     </p:embeddedFont>
   </p:embeddedFontLst>
   <p:defaultTextStyle>
@@ -409,6 +412,90 @@
             <a:fld id="{F7021451-1387-4CA6-816F-3879F97B5CBC}" type="slidenum">
               <a:rPr lang="en-US"/>
               <a:t>10</a:t>
+            </a:fld>
+            <a:endParaRPr lang="en-US"/>
+          </a:p>
+        </p:txBody>
+      </p:sp>
+    </p:spTree>
+    <p:extLst>
+      <p:ext uri="{BB962C8B-B14F-4D97-AF65-F5344CB8AC3E}">
+        <p14:creationId xmlns:p14="http://schemas.microsoft.com/office/powerpoint/2010/main" val="1024086991"/>
+      </p:ext>
+    </p:extLst>
+  </p:cSld>
+  <p:clrMapOvr>
+    <a:masterClrMapping/>
+  </p:clrMapOvr>
+</p:notes>
+</file>
+
+<file path=ppt/notesSlides/notesSlide11.xml><?xml version="1.0" encoding="utf-8"?>
+<p:notes xmlns:a="http://schemas.openxmlformats.org/drawingml/2006/main" xmlns:r="http://schemas.openxmlformats.org/officeDocument/2006/relationships" xmlns:p="http://schemas.openxmlformats.org/presentationml/2006/main">
+  <p:cSld>
+    <p:spTree>
+      <p:nvGrpSpPr>
+        <p:cNvPr id="1" name=""/>
+        <p:cNvGrpSpPr/>
+        <p:nvPr/>
+      </p:nvGrpSpPr>
+      <p:grpSpPr>
+        <a:xfrm>
+          <a:off x="0" y="0"/>
+          <a:ext cx="0" cy="0"/>
+          <a:chOff x="0" y="0"/>
+          <a:chExt cx="0" cy="0"/>
+        </a:xfrm>
+      </p:grpSpPr>
+      <p:sp>
+        <p:nvSpPr>
+          <p:cNvPr id="2" name="Slide Image Placeholder 1"/>
+          <p:cNvSpPr>
+            <a:spLocks noGrp="1" noRot="1" noChangeAspect="1"/>
+          </p:cNvSpPr>
+          <p:nvPr>
+            <p:ph type="sldImg"/>
+          </p:nvPr>
+        </p:nvSpPr>
+        <p:spPr/>
+      </p:sp>
+      <p:sp>
+        <p:nvSpPr>
+          <p:cNvPr id="3" name="Notes Placeholder 2"/>
+          <p:cNvSpPr>
+            <a:spLocks noGrp="1"/>
+          </p:cNvSpPr>
+          <p:nvPr>
+            <p:ph type="body" idx="1"/>
+          </p:nvPr>
+        </p:nvSpPr>
+        <p:spPr/>
+        <p:txBody>
+          <a:bodyPr/>
+          <a:lstStyle/>
+          <a:p>
+            <a:endParaRPr lang="en-US" dirty="0"/>
+          </a:p>
+        </p:txBody>
+      </p:sp>
+      <p:sp>
+        <p:nvSpPr>
+          <p:cNvPr id="4" name="Slide Number Placeholder 3"/>
+          <p:cNvSpPr>
+            <a:spLocks noGrp="1"/>
+          </p:cNvSpPr>
+          <p:nvPr>
+            <p:ph type="sldNum" sz="quarter" idx="10"/>
+          </p:nvPr>
+        </p:nvSpPr>
+        <p:spPr/>
+        <p:txBody>
+          <a:bodyPr/>
+          <a:lstStyle/>
+          <a:p>
+            <a:fld id="{F7021451-1387-4CA6-816F-3879F97B5CBC}" type="slidenum">
+              <a:rPr lang="en-US"/>
+              <a:t>11</a:t>
             </a:fld>
             <a:endParaRPr lang="en-US"/>
           </a:p>
@@ -2216,6 +2303,1415 @@
               <a:t>10</a:t>
             </a:r>
             <a:endParaRPr lang="en-US" sz="1600" dirty="0"/>
+          </a:p>
+        </p:txBody>
+      </p:sp>
+    </p:spTree>
+  </p:cSld>
+  <p:clrMapOvr>
+    <a:masterClrMapping/>
+  </p:clrMapOvr>
+  <p:transition>
+    <p:fade/>
+  </p:transition>
+</p:sld>
+</file>
+
+<file path=ppt/slides/slide11.xml><?xml version="1.0" encoding="utf-8"?>
+<p:sld xmlns:a="http://schemas.openxmlformats.org/drawingml/2006/main" xmlns:r="http://schemas.openxmlformats.org/officeDocument/2006/relationships" xmlns:p="http://schemas.openxmlformats.org/presentationml/2006/main">
+  <p:cSld>
+    <p:spTree>
+      <p:nvGrpSpPr>
+        <p:cNvPr id="1" name=""/>
+        <p:cNvGrpSpPr/>
+        <p:nvPr/>
+      </p:nvGrpSpPr>
+      <p:grpSpPr>
+        <a:xfrm>
+          <a:off x="0" y="0"/>
+          <a:ext cx="0" cy="0"/>
+          <a:chOff x="0" y="0"/>
+          <a:chExt cx="0" cy="0"/>
+        </a:xfrm>
+      </p:grpSpPr>
+      <p:sp>
+        <p:nvSpPr>
+          <p:cNvPr id="2" name="Shape 0"/>
+          <p:cNvSpPr/>
+          <p:nvPr/>
+        </p:nvSpPr>
+        <p:spPr>
+          <a:xfrm>
+            <a:off x="761851" y="572281"/>
+            <a:ext cx="11427768" cy="533296"/>
+          </a:xfrm>
+          <a:prstGeom prst="rect">
+            <a:avLst/>
+          </a:prstGeom>
+          <a:noFill/>
+          <a:ln/>
+        </p:spPr>
+        <p:txBody>
+          <a:bodyPr/>
+          <a:lstStyle/>
+          <a:p>
+            <a:endParaRPr lang="en-US" sz="1350"/>
+          </a:p>
+        </p:txBody>
+      </p:sp>
+      <p:sp>
+        <p:nvSpPr>
+          <p:cNvPr id="3" name="Text 1"/>
+          <p:cNvSpPr/>
+          <p:nvPr/>
+        </p:nvSpPr>
+        <p:spPr>
+          <a:xfrm>
+            <a:off x="670429" y="526570"/>
+            <a:ext cx="11610612" cy="624718"/>
+          </a:xfrm>
+          <a:prstGeom prst="rect">
+            <a:avLst/>
+          </a:prstGeom>
+          <a:noFill/>
+          <a:ln/>
+        </p:spPr>
+        <p:txBody>
+          <a:bodyPr wrap="none" lIns="0" tIns="0" rIns="0" bIns="0" rtlCol="0" anchor="t"/>
+          <a:lstStyle/>
+          <a:p>
+            <a:pPr algn="l">
+              <a:lnSpc>
+                <a:spcPct val="130000"/>
+              </a:lnSpc>
+            </a:pPr>
+            <a:r>
+              <a:rPr lang="en-US" sz="3000" kern="0" spc="200" dirty="0">
+                <a:solidFill>
+                  <a:srgbClr val="1E2D3D"/>
+                </a:solidFill>
+                <a:latin typeface="Liter" pitchFamily="34" charset="0"/>
+                <a:ea typeface="Liter" pitchFamily="34" charset="-122"/>
+                <a:cs typeface="Liter" pitchFamily="34" charset="-120"/>
+              </a:rPr>
+              <a:t>FOUNDER BACKGROUND</a:t>
+            </a:r>
+            <a:endParaRPr lang="en-US" sz="3000" dirty="0"/>
+          </a:p>
+        </p:txBody>
+      </p:sp>
+      <p:sp>
+        <p:nvSpPr>
+          <p:cNvPr id="4" name="Shape 2"/>
+          <p:cNvSpPr/>
+          <p:nvPr/>
+        </p:nvSpPr>
+        <p:spPr>
+          <a:xfrm>
+            <a:off x="761851" y="1169096"/>
+            <a:ext cx="634908" cy="38093"/>
+          </a:xfrm>
+          <a:prstGeom prst="rect">
+            <a:avLst/>
+          </a:prstGeom>
+          <a:solidFill>
+            <a:srgbClr val="C4956A"/>
+          </a:solidFill>
+          <a:ln/>
+        </p:spPr>
+        <p:txBody>
+          <a:bodyPr/>
+          <a:lstStyle/>
+          <a:p>
+            <a:endParaRPr lang="en-US" sz="1350"/>
+          </a:p>
+        </p:txBody>
+      </p:sp>
+      <p:sp>
+        <p:nvSpPr>
+          <p:cNvPr id="5" name="Shape 3"/>
+          <p:cNvSpPr/>
+          <p:nvPr/>
+        </p:nvSpPr>
+        <p:spPr>
+          <a:xfrm>
+            <a:off x="761851" y="1353179"/>
+            <a:ext cx="13967304" cy="476157"/>
+          </a:xfrm>
+          <a:prstGeom prst="rect">
+            <a:avLst/>
+          </a:prstGeom>
+          <a:noFill/>
+          <a:ln/>
+        </p:spPr>
+        <p:txBody>
+          <a:bodyPr/>
+          <a:lstStyle/>
+          <a:p>
+            <a:endParaRPr lang="en-US" sz="1350"/>
+          </a:p>
+        </p:txBody>
+      </p:sp>
+      <p:sp>
+        <p:nvSpPr>
+          <p:cNvPr id="6" name="Text 4"/>
+          <p:cNvSpPr/>
+          <p:nvPr/>
+        </p:nvSpPr>
+        <p:spPr>
+          <a:xfrm>
+            <a:off x="670429" y="1307468"/>
+            <a:ext cx="14150148" cy="563770"/>
+          </a:xfrm>
+          <a:prstGeom prst="rect">
+            <a:avLst/>
+          </a:prstGeom>
+          <a:noFill/>
+          <a:ln/>
+        </p:spPr>
+        <p:txBody>
+          <a:bodyPr wrap="none" lIns="0" tIns="0" rIns="0" bIns="0" rtlCol="0" anchor="t"/>
+          <a:lstStyle/>
+          <a:p>
+            <a:pPr algn="l">
+              <a:lnSpc>
+                <a:spcPct val="130000"/>
+              </a:lnSpc>
+            </a:pPr>
+            <a:r>
+              <a:rPr lang="en-US" dirty="0">
+                <a:solidFill>
+                  <a:srgbClr val="6B7B8D"/>
+                </a:solidFill>
+                <a:latin typeface="Quattrocento Sans" pitchFamily="34" charset="0"/>
+                <a:ea typeface="Quattrocento Sans" pitchFamily="34" charset="-122"/>
+                <a:cs typeface="Quattrocento Sans" pitchFamily="34" charset="-120"/>
+              </a:rPr>
+              <a:t>30+ years of leadership across staffing, campus engagement, and talent development.</a:t>
+            </a:r>
+            <a:endParaRPr lang="en-US" dirty="0"/>
+          </a:p>
+        </p:txBody>
+      </p:sp>
+      <p:sp>
+        <p:nvSpPr>
+          <p:cNvPr id="7" name="Shape 5"/>
+          <p:cNvSpPr/>
+          <p:nvPr/>
+        </p:nvSpPr>
+        <p:spPr>
+          <a:xfrm>
+            <a:off x="761852" y="2000752"/>
+            <a:ext cx="14729155" cy="857083"/>
+          </a:xfrm>
+          <a:prstGeom prst="rect">
+            <a:avLst/>
+          </a:prstGeom>
+          <a:solidFill>
+            <a:srgbClr val="1E2D3D"/>
+          </a:solidFill>
+          <a:ln/>
+        </p:spPr>
+        <p:txBody>
+          <a:bodyPr/>
+          <a:lstStyle/>
+          <a:p>
+            <a:endParaRPr lang="en-US" sz="1350"/>
+          </a:p>
+        </p:txBody>
+      </p:sp>
+      <p:sp>
+        <p:nvSpPr>
+          <p:cNvPr id="8" name="Shape 6"/>
+          <p:cNvSpPr/>
+          <p:nvPr/>
+        </p:nvSpPr>
+        <p:spPr>
+          <a:xfrm>
+            <a:off x="1142777" y="2095983"/>
+            <a:ext cx="13967304" cy="666620"/>
+          </a:xfrm>
+          <a:prstGeom prst="rect">
+            <a:avLst/>
+          </a:prstGeom>
+          <a:noFill/>
+          <a:ln/>
+        </p:spPr>
+        <p:txBody>
+          <a:bodyPr/>
+          <a:lstStyle/>
+          <a:p>
+            <a:endParaRPr lang="en-US" sz="1350"/>
+          </a:p>
+        </p:txBody>
+      </p:sp>
+      <p:sp>
+        <p:nvSpPr>
+          <p:cNvPr id="9" name="Text 7"/>
+          <p:cNvSpPr/>
+          <p:nvPr/>
+        </p:nvSpPr>
+        <p:spPr>
+          <a:xfrm>
+            <a:off x="1051355" y="2050272"/>
+            <a:ext cx="14150148" cy="758042"/>
+          </a:xfrm>
+          <a:prstGeom prst="rect">
+            <a:avLst/>
+          </a:prstGeom>
+          <a:noFill/>
+          <a:ln/>
+        </p:spPr>
+        <p:txBody>
+          <a:bodyPr wrap="square" lIns="0" tIns="0" rIns="0" bIns="0" rtlCol="0" anchor="ctr"/>
+          <a:lstStyle/>
+          <a:p>
+            <a:pPr algn="l">
+              <a:lnSpc>
+                <a:spcPct val="140000"/>
+              </a:lnSpc>
+            </a:pPr>
+            <a:r>
+              <a:rPr lang="en-US" sz="1650" i="1" dirty="0">
+                <a:solidFill>
+                  <a:srgbClr val="F5F3EF"/>
+                </a:solidFill>
+                <a:latin typeface="Quattrocento Sans" pitchFamily="34" charset="0"/>
+                <a:ea typeface="Quattrocento Sans" pitchFamily="34" charset="-122"/>
+                <a:cs typeface="Quattrocento Sans" pitchFamily="34" charset="-120"/>
+              </a:rPr>
+              <a:t>"Experienced leader in staffing, campus engagement, talent development, and large-scale program delivery with 30+ years of industry experience."</a:t>
+            </a:r>
+            <a:endParaRPr lang="en-US" sz="1650" dirty="0"/>
+          </a:p>
+        </p:txBody>
+      </p:sp>
+      <p:sp>
+        <p:nvSpPr>
+          <p:cNvPr id="10" name="Shape 8"/>
+          <p:cNvSpPr/>
+          <p:nvPr/>
+        </p:nvSpPr>
+        <p:spPr>
+          <a:xfrm>
+            <a:off x="761851" y="3143529"/>
+            <a:ext cx="7047124" cy="5142496"/>
+          </a:xfrm>
+          <a:prstGeom prst="rect">
+            <a:avLst/>
+          </a:prstGeom>
+          <a:solidFill>
+            <a:srgbClr val="FFFFFF"/>
+          </a:solidFill>
+          <a:ln/>
+          <a:effectLst>
+            <a:outerShdw blurRad="127000" dist="50800" dir="60000" algn="bl" rotWithShape="0">
+              <a:srgbClr val="000000">
+                <a:alpha val="4706"/>
+              </a:srgbClr>
+            </a:outerShdw>
+          </a:effectLst>
+        </p:spPr>
+        <p:txBody>
+          <a:bodyPr/>
+          <a:lstStyle/>
+          <a:p>
+            <a:endParaRPr lang="en-US" sz="1350"/>
+          </a:p>
+        </p:txBody>
+      </p:sp>
+      <p:sp>
+        <p:nvSpPr>
+          <p:cNvPr id="11" name="Shape 9"/>
+          <p:cNvSpPr/>
+          <p:nvPr/>
+        </p:nvSpPr>
+        <p:spPr>
+          <a:xfrm>
+            <a:off x="761851" y="3143530"/>
+            <a:ext cx="7047124" cy="50758"/>
+          </a:xfrm>
+          <a:prstGeom prst="rect">
+            <a:avLst/>
+          </a:prstGeom>
+          <a:solidFill>
+            <a:srgbClr val="C4956A"/>
+          </a:solidFill>
+          <a:ln/>
+        </p:spPr>
+        <p:txBody>
+          <a:bodyPr/>
+          <a:lstStyle/>
+          <a:p>
+            <a:endParaRPr lang="en-US" sz="1350"/>
+          </a:p>
+        </p:txBody>
+      </p:sp>
+      <p:sp>
+        <p:nvSpPr>
+          <p:cNvPr id="12" name="Shape 10"/>
+          <p:cNvSpPr/>
+          <p:nvPr/>
+        </p:nvSpPr>
+        <p:spPr>
+          <a:xfrm>
+            <a:off x="1066592" y="3391131"/>
+            <a:ext cx="355499" cy="355499"/>
+          </a:xfrm>
+          <a:custGeom>
+            <a:avLst/>
+            <a:gdLst/>
+            <a:ahLst/>
+            <a:cxnLst/>
+            <a:rect l="l" t="t" r="r" b="b"/>
+            <a:pathLst>
+              <a:path w="474091" h="474091">
+                <a:moveTo>
+                  <a:pt x="237046" y="474091"/>
+                </a:moveTo>
+                <a:cubicBezTo>
+                  <a:pt x="367874" y="474091"/>
+                  <a:pt x="474091" y="367874"/>
+                  <a:pt x="474091" y="237046"/>
+                </a:cubicBezTo>
+                <a:cubicBezTo>
+                  <a:pt x="474091" y="106217"/>
+                  <a:pt x="367874" y="0"/>
+                  <a:pt x="237046" y="0"/>
+                </a:cubicBezTo>
+                <a:cubicBezTo>
+                  <a:pt x="106217" y="0"/>
+                  <a:pt x="0" y="106217"/>
+                  <a:pt x="0" y="237046"/>
+                </a:cubicBezTo>
+                <a:cubicBezTo>
+                  <a:pt x="0" y="367874"/>
+                  <a:pt x="106217" y="474091"/>
+                  <a:pt x="237046" y="474091"/>
+                </a:cubicBezTo>
+                <a:close/>
+                <a:moveTo>
+                  <a:pt x="237046" y="71060"/>
+                </a:moveTo>
+                <a:cubicBezTo>
+                  <a:pt x="327975" y="71060"/>
+                  <a:pt x="402231" y="145316"/>
+                  <a:pt x="402231" y="236246"/>
+                </a:cubicBezTo>
+                <a:cubicBezTo>
+                  <a:pt x="402231" y="327175"/>
+                  <a:pt x="327975" y="401431"/>
+                  <a:pt x="237046" y="401431"/>
+                </a:cubicBezTo>
+                <a:cubicBezTo>
+                  <a:pt x="146116" y="401431"/>
+                  <a:pt x="71860" y="327175"/>
+                  <a:pt x="71860" y="236246"/>
+                </a:cubicBezTo>
+                <a:cubicBezTo>
+                  <a:pt x="71860" y="145316"/>
+                  <a:pt x="146116" y="71060"/>
+                  <a:pt x="237046" y="71060"/>
+                </a:cubicBezTo>
+                <a:close/>
+                <a:moveTo>
+                  <a:pt x="237046" y="315794"/>
+                </a:moveTo>
+                <a:cubicBezTo>
+                  <a:pt x="280182" y="315794"/>
+                  <a:pt x="315794" y="280182"/>
+                  <a:pt x="315794" y="237046"/>
+                </a:cubicBezTo>
+                <a:cubicBezTo>
+                  <a:pt x="315794" y="193909"/>
+                  <a:pt x="280182" y="158297"/>
+                  <a:pt x="237046" y="158297"/>
+                </a:cubicBezTo>
+                <a:cubicBezTo>
+                  <a:pt x="193909" y="158297"/>
+                  <a:pt x="158297" y="193909"/>
+                  <a:pt x="158297" y="237046"/>
+                </a:cubicBezTo>
+                <a:cubicBezTo>
+                  <a:pt x="158297" y="280182"/>
+                  <a:pt x="193909" y="315794"/>
+                  <a:pt x="237046" y="315794"/>
+                </a:cubicBezTo>
+                <a:close/>
+                <a:moveTo>
+                  <a:pt x="237046" y="270909"/>
+                </a:moveTo>
+                <a:cubicBezTo>
+                  <a:pt x="217555" y="270909"/>
+                  <a:pt x="201849" y="255203"/>
+                  <a:pt x="201849" y="237046"/>
+                </a:cubicBezTo>
+                <a:cubicBezTo>
+                  <a:pt x="201849" y="218888"/>
+                  <a:pt x="217555" y="203182"/>
+                  <a:pt x="237046" y="203182"/>
+                </a:cubicBezTo>
+                <a:cubicBezTo>
+                  <a:pt x="255203" y="203182"/>
+                  <a:pt x="270909" y="218888"/>
+                  <a:pt x="270909" y="237046"/>
+                </a:cubicBezTo>
+                <a:cubicBezTo>
+                  <a:pt x="270909" y="255203"/>
+                  <a:pt x="255203" y="270909"/>
+                  <a:pt x="237046" y="270909"/>
+                </a:cubicBezTo>
+                <a:close/>
+              </a:path>
+            </a:pathLst>
+          </a:custGeom>
+          <a:solidFill>
+            <a:srgbClr val="C4956A"/>
+          </a:solidFill>
+          <a:ln/>
+        </p:spPr>
+        <p:txBody>
+          <a:bodyPr/>
+          <a:lstStyle/>
+          <a:p>
+            <a:endParaRPr lang="en-US" sz="1350"/>
+          </a:p>
+        </p:txBody>
+      </p:sp>
+      <p:sp>
+        <p:nvSpPr>
+          <p:cNvPr id="13" name="Shape 11"/>
+          <p:cNvSpPr/>
+          <p:nvPr/>
+        </p:nvSpPr>
+        <p:spPr>
+          <a:xfrm>
+            <a:off x="1523703" y="3391130"/>
+            <a:ext cx="5999578" cy="380926"/>
+          </a:xfrm>
+          <a:prstGeom prst="rect">
+            <a:avLst/>
+          </a:prstGeom>
+          <a:noFill/>
+          <a:ln/>
+        </p:spPr>
+        <p:txBody>
+          <a:bodyPr/>
+          <a:lstStyle/>
+          <a:p>
+            <a:endParaRPr lang="en-US" sz="1350"/>
+          </a:p>
+        </p:txBody>
+      </p:sp>
+      <p:sp>
+        <p:nvSpPr>
+          <p:cNvPr id="14" name="Text 12"/>
+          <p:cNvSpPr/>
+          <p:nvPr/>
+        </p:nvSpPr>
+        <p:spPr>
+          <a:xfrm>
+            <a:off x="1432280" y="3345419"/>
+            <a:ext cx="6186232" cy="472348"/>
+          </a:xfrm>
+          <a:prstGeom prst="rect">
+            <a:avLst/>
+          </a:prstGeom>
+          <a:noFill/>
+          <a:ln/>
+        </p:spPr>
+        <p:txBody>
+          <a:bodyPr wrap="none" lIns="0" tIns="0" rIns="0" bIns="0" rtlCol="0" anchor="t"/>
+          <a:lstStyle/>
+          <a:p>
+            <a:pPr algn="l">
+              <a:lnSpc>
+                <a:spcPct val="130000"/>
+              </a:lnSpc>
+            </a:pPr>
+            <a:r>
+              <a:rPr lang="en-US" dirty="0">
+                <a:solidFill>
+                  <a:srgbClr val="1E2D3D"/>
+                </a:solidFill>
+                <a:latin typeface="Liter" pitchFamily="34" charset="0"/>
+                <a:ea typeface="Liter" pitchFamily="34" charset="-122"/>
+                <a:cs typeface="Liter" pitchFamily="34" charset="-120"/>
+              </a:rPr>
+              <a:t>Leadership &amp; Experience</a:t>
+            </a:r>
+            <a:endParaRPr lang="en-US" dirty="0"/>
+          </a:p>
+        </p:txBody>
+      </p:sp>
+      <p:sp>
+        <p:nvSpPr>
+          <p:cNvPr id="15" name="Shape 13"/>
+          <p:cNvSpPr/>
+          <p:nvPr/>
+        </p:nvSpPr>
+        <p:spPr>
+          <a:xfrm>
+            <a:off x="1066592" y="3905380"/>
+            <a:ext cx="6437643" cy="4190182"/>
+          </a:xfrm>
+          <a:prstGeom prst="rect">
+            <a:avLst/>
+          </a:prstGeom>
+          <a:noFill/>
+          <a:ln/>
+        </p:spPr>
+        <p:txBody>
+          <a:bodyPr/>
+          <a:lstStyle/>
+          <a:p>
+            <a:endParaRPr lang="en-US" sz="1350"/>
+          </a:p>
+        </p:txBody>
+      </p:sp>
+      <p:sp>
+        <p:nvSpPr>
+          <p:cNvPr id="16" name="Text 14"/>
+          <p:cNvSpPr/>
+          <p:nvPr/>
+        </p:nvSpPr>
+        <p:spPr>
+          <a:xfrm>
+            <a:off x="975170" y="3859669"/>
+            <a:ext cx="6623058" cy="4281604"/>
+          </a:xfrm>
+          <a:prstGeom prst="rect">
+            <a:avLst/>
+          </a:prstGeom>
+          <a:noFill/>
+          <a:ln/>
+        </p:spPr>
+        <p:txBody>
+          <a:bodyPr wrap="square" lIns="0" tIns="0" rIns="0" bIns="0" rtlCol="0" anchor="t"/>
+          <a:lstStyle/>
+          <a:p>
+            <a:pPr algn="l">
+              <a:lnSpc>
+                <a:spcPct val="170000"/>
+              </a:lnSpc>
+            </a:pPr>
+            <a:r>
+              <a:rPr lang="en-US" sz="1500" b="1" dirty="0">
+                <a:solidFill>
+                  <a:srgbClr val="1E2D3D"/>
+                </a:solidFill>
+                <a:latin typeface="Quattrocento Sans" pitchFamily="34" charset="0"/>
+                <a:ea typeface="Quattrocento Sans" pitchFamily="34" charset="-122"/>
+                <a:cs typeface="Quattrocento Sans" pitchFamily="34" charset="-120"/>
+              </a:rPr>
+              <a:t>30+ years</a:t>
+            </a:r>
+            <a:r>
+              <a:rPr lang="en-US" sz="1500" dirty="0">
+                <a:solidFill>
+                  <a:srgbClr val="1E2D3D"/>
+                </a:solidFill>
+                <a:latin typeface="Quattrocento Sans" pitchFamily="34" charset="0"/>
+                <a:ea typeface="Quattrocento Sans" pitchFamily="34" charset="-122"/>
+                <a:cs typeface="Quattrocento Sans" pitchFamily="34" charset="-120"/>
+              </a:rPr>
+              <a:t> of leadership experience across enterprise and startup environments.</a:t>
+            </a:r>
+            <a:endParaRPr lang="en-US" sz="1500" dirty="0"/>
+          </a:p>
+          <a:p>
+            <a:pPr algn="l">
+              <a:lnSpc>
+                <a:spcPct val="170000"/>
+              </a:lnSpc>
+            </a:pPr>
+            <a:r>
+              <a:rPr lang="en-US" sz="1500" dirty="0">
+                <a:solidFill>
+                  <a:srgbClr val="1E2D3D"/>
+                </a:solidFill>
+                <a:latin typeface="Quattrocento Sans" pitchFamily="34" charset="0"/>
+                <a:ea typeface="Quattrocento Sans" pitchFamily="34" charset="-122"/>
+                <a:cs typeface="Quattrocento Sans" pitchFamily="34" charset="-120"/>
+              </a:rPr>
+              <a:t>Led </a:t>
+            </a:r>
+            <a:r>
+              <a:rPr lang="en-US" sz="1500" b="1" dirty="0">
+                <a:solidFill>
+                  <a:srgbClr val="1E2D3D"/>
+                </a:solidFill>
+                <a:latin typeface="Quattrocento Sans" pitchFamily="34" charset="0"/>
+                <a:ea typeface="Quattrocento Sans" pitchFamily="34" charset="-122"/>
+                <a:cs typeface="Quattrocento Sans" pitchFamily="34" charset="-120"/>
+              </a:rPr>
+              <a:t>recruitment, workforce planning, and talent acquisition</a:t>
+            </a:r>
+            <a:r>
+              <a:rPr lang="en-US" sz="1500" dirty="0">
+                <a:solidFill>
+                  <a:srgbClr val="1E2D3D"/>
+                </a:solidFill>
+                <a:latin typeface="Quattrocento Sans" pitchFamily="34" charset="0"/>
+                <a:ea typeface="Quattrocento Sans" pitchFamily="34" charset="-122"/>
+                <a:cs typeface="Quattrocento Sans" pitchFamily="34" charset="-120"/>
+              </a:rPr>
+              <a:t> initiatives across multiple organizations.</a:t>
+            </a:r>
+            <a:endParaRPr lang="en-US" sz="1500" dirty="0"/>
+          </a:p>
+          <a:p>
+            <a:pPr algn="l">
+              <a:lnSpc>
+                <a:spcPct val="170000"/>
+              </a:lnSpc>
+            </a:pPr>
+            <a:r>
+              <a:rPr lang="en-US" sz="1500" dirty="0">
+                <a:solidFill>
+                  <a:srgbClr val="1E2D3D"/>
+                </a:solidFill>
+                <a:latin typeface="Quattrocento Sans" pitchFamily="34" charset="0"/>
+                <a:ea typeface="Quattrocento Sans" pitchFamily="34" charset="-122"/>
+                <a:cs typeface="Quattrocento Sans" pitchFamily="34" charset="-120"/>
+              </a:rPr>
+              <a:t>Built and mentored </a:t>
+            </a:r>
+            <a:r>
+              <a:rPr lang="en-US" sz="1500" b="1" dirty="0">
+                <a:solidFill>
+                  <a:srgbClr val="1E2D3D"/>
+                </a:solidFill>
+                <a:latin typeface="Quattrocento Sans" pitchFamily="34" charset="0"/>
+                <a:ea typeface="Quattrocento Sans" pitchFamily="34" charset="-122"/>
+                <a:cs typeface="Quattrocento Sans" pitchFamily="34" charset="-120"/>
+              </a:rPr>
+              <a:t>high-performing delivery, project, and operations teams</a:t>
+            </a:r>
+            <a:r>
+              <a:rPr lang="en-US" sz="1500" dirty="0">
+                <a:solidFill>
+                  <a:srgbClr val="1E2D3D"/>
+                </a:solidFill>
+                <a:latin typeface="Quattrocento Sans" pitchFamily="34" charset="0"/>
+                <a:ea typeface="Quattrocento Sans" pitchFamily="34" charset="-122"/>
+                <a:cs typeface="Quattrocento Sans" pitchFamily="34" charset="-120"/>
+              </a:rPr>
+              <a:t> in India and international markets.</a:t>
+            </a:r>
+            <a:endParaRPr lang="en-US" sz="1500" dirty="0"/>
+          </a:p>
+          <a:p>
+            <a:pPr algn="l">
+              <a:lnSpc>
+                <a:spcPct val="170000"/>
+              </a:lnSpc>
+            </a:pPr>
+            <a:r>
+              <a:rPr lang="en-US" sz="1500" dirty="0">
+                <a:solidFill>
+                  <a:srgbClr val="1E2D3D"/>
+                </a:solidFill>
+                <a:latin typeface="Quattrocento Sans" pitchFamily="34" charset="0"/>
+                <a:ea typeface="Quattrocento Sans" pitchFamily="34" charset="-122"/>
+                <a:cs typeface="Quattrocento Sans" pitchFamily="34" charset="-120"/>
+              </a:rPr>
+              <a:t>Successfully scaled teams while maintaining delivery excellence, governance, and operational efficiency.</a:t>
+            </a:r>
+          </a:p>
+          <a:p>
+            <a:pPr>
+              <a:lnSpc>
+                <a:spcPct val="170000"/>
+              </a:lnSpc>
+            </a:pPr>
+            <a:r>
+              <a:rPr lang="en-US" sz="1500" dirty="0">
+                <a:solidFill>
+                  <a:srgbClr val="1E2D3D"/>
+                </a:solidFill>
+                <a:latin typeface="Quattrocento Sans" pitchFamily="34" charset="0"/>
+                <a:ea typeface="Quattrocento Sans" pitchFamily="34" charset="-122"/>
+                <a:cs typeface="Quattrocento Sans" pitchFamily="34" charset="-120"/>
+              </a:rPr>
+              <a:t>LinkedIn Profile: </a:t>
+            </a:r>
+            <a:r>
+              <a:rPr lang="en-US" sz="1500" dirty="0">
+                <a:solidFill>
+                  <a:srgbClr val="1E2D3D"/>
+                </a:solidFill>
+                <a:latin typeface="Quattrocento Sans" pitchFamily="34" charset="0"/>
+                <a:ea typeface="Quattrocento Sans" pitchFamily="34" charset="-122"/>
+                <a:cs typeface="Quattrocento Sans" pitchFamily="34" charset="-120"/>
+                <a:hlinkClick r:id="rId3"/>
+              </a:rPr>
+              <a:t>https://www.linkedin.com/in/jain35/</a:t>
+            </a:r>
+            <a:endParaRPr lang="en-US" sz="1500" dirty="0">
+              <a:solidFill>
+                <a:srgbClr val="1E2D3D"/>
+              </a:solidFill>
+              <a:latin typeface="Quattrocento Sans" pitchFamily="34" charset="0"/>
+              <a:ea typeface="Quattrocento Sans" pitchFamily="34" charset="-122"/>
+              <a:cs typeface="Quattrocento Sans" pitchFamily="34" charset="-120"/>
+            </a:endParaRPr>
+          </a:p>
+          <a:p>
+            <a:pPr algn="l">
+              <a:lnSpc>
+                <a:spcPct val="170000"/>
+              </a:lnSpc>
+            </a:pPr>
+            <a:r>
+              <a:rPr lang="en-US" sz="1500" dirty="0">
+                <a:solidFill>
+                  <a:srgbClr val="1E2D3D"/>
+                </a:solidFill>
+                <a:latin typeface="Quattrocento Sans" pitchFamily="34" charset="0"/>
+                <a:ea typeface="Quattrocento Sans" pitchFamily="34" charset="-122"/>
+                <a:cs typeface="Quattrocento Sans" pitchFamily="34" charset="-120"/>
+              </a:rPr>
+              <a:t>Detailed Profile: </a:t>
+            </a:r>
+            <a:r>
+              <a:rPr lang="en-US" sz="1500" dirty="0">
+                <a:hlinkClick r:id="rId4"/>
+              </a:rPr>
+              <a:t>Summary | Sandeep Jain</a:t>
+            </a:r>
+            <a:endParaRPr lang="en-US" sz="1500" dirty="0"/>
+          </a:p>
+        </p:txBody>
+      </p:sp>
+      <p:sp>
+        <p:nvSpPr>
+          <p:cNvPr id="17" name="Shape 15"/>
+          <p:cNvSpPr/>
+          <p:nvPr/>
+        </p:nvSpPr>
+        <p:spPr>
+          <a:xfrm>
+            <a:off x="8189901" y="3143529"/>
+            <a:ext cx="7301106" cy="5142496"/>
+          </a:xfrm>
+          <a:prstGeom prst="rect">
+            <a:avLst/>
+          </a:prstGeom>
+          <a:solidFill>
+            <a:srgbClr val="FFFFFF"/>
+          </a:solidFill>
+          <a:ln/>
+          <a:effectLst>
+            <a:outerShdw blurRad="127000" dist="50800" dir="60000" algn="bl" rotWithShape="0">
+              <a:srgbClr val="000000">
+                <a:alpha val="4706"/>
+              </a:srgbClr>
+            </a:outerShdw>
+          </a:effectLst>
+        </p:spPr>
+        <p:txBody>
+          <a:bodyPr/>
+          <a:lstStyle/>
+          <a:p>
+            <a:endParaRPr lang="en-US" sz="1350"/>
+          </a:p>
+        </p:txBody>
+      </p:sp>
+      <p:sp>
+        <p:nvSpPr>
+          <p:cNvPr id="18" name="Shape 16"/>
+          <p:cNvSpPr/>
+          <p:nvPr/>
+        </p:nvSpPr>
+        <p:spPr>
+          <a:xfrm>
+            <a:off x="8189901" y="3143530"/>
+            <a:ext cx="7301106" cy="50758"/>
+          </a:xfrm>
+          <a:prstGeom prst="rect">
+            <a:avLst/>
+          </a:prstGeom>
+          <a:solidFill>
+            <a:srgbClr val="1E2D3D"/>
+          </a:solidFill>
+          <a:ln/>
+        </p:spPr>
+        <p:txBody>
+          <a:bodyPr/>
+          <a:lstStyle/>
+          <a:p>
+            <a:endParaRPr lang="en-US" sz="1350"/>
+          </a:p>
+        </p:txBody>
+      </p:sp>
+      <p:sp>
+        <p:nvSpPr>
+          <p:cNvPr id="19" name="Shape 17"/>
+          <p:cNvSpPr/>
+          <p:nvPr/>
+        </p:nvSpPr>
+        <p:spPr>
+          <a:xfrm>
+            <a:off x="8494641" y="3391131"/>
+            <a:ext cx="355499" cy="355499"/>
+          </a:xfrm>
+          <a:custGeom>
+            <a:avLst/>
+            <a:gdLst/>
+            <a:ahLst/>
+            <a:cxnLst/>
+            <a:rect l="l" t="t" r="r" b="b"/>
+            <a:pathLst>
+              <a:path w="474091" h="474091">
+                <a:moveTo>
+                  <a:pt x="255354" y="-12038"/>
+                </a:moveTo>
+                <a:cubicBezTo>
+                  <a:pt x="243289" y="-14167"/>
+                  <a:pt x="230908" y="-14167"/>
+                  <a:pt x="218844" y="-12038"/>
+                </a:cubicBezTo>
+                <a:lnTo>
+                  <a:pt x="20424" y="22686"/>
+                </a:lnTo>
+                <a:cubicBezTo>
+                  <a:pt x="8572" y="24723"/>
+                  <a:pt x="0" y="33890"/>
+                  <a:pt x="0" y="44446"/>
+                </a:cubicBezTo>
+                <a:cubicBezTo>
+                  <a:pt x="0" y="53984"/>
+                  <a:pt x="6878" y="62317"/>
+                  <a:pt x="16931" y="65373"/>
+                </a:cubicBezTo>
+                <a:lnTo>
+                  <a:pt x="16931" y="133338"/>
+                </a:lnTo>
+                <a:lnTo>
+                  <a:pt x="317" y="206119"/>
+                </a:lnTo>
+                <a:cubicBezTo>
+                  <a:pt x="106" y="206952"/>
+                  <a:pt x="0" y="207878"/>
+                  <a:pt x="0" y="208804"/>
+                </a:cubicBezTo>
+                <a:cubicBezTo>
+                  <a:pt x="0" y="216212"/>
+                  <a:pt x="6878" y="222322"/>
+                  <a:pt x="15450" y="222322"/>
+                </a:cubicBezTo>
+                <a:lnTo>
+                  <a:pt x="52383" y="222322"/>
+                </a:lnTo>
+                <a:cubicBezTo>
+                  <a:pt x="60849" y="222322"/>
+                  <a:pt x="67833" y="216304"/>
+                  <a:pt x="67833" y="208804"/>
+                </a:cubicBezTo>
+                <a:cubicBezTo>
+                  <a:pt x="67833" y="207878"/>
+                  <a:pt x="67727" y="207045"/>
+                  <a:pt x="67516" y="206119"/>
+                </a:cubicBezTo>
+                <a:lnTo>
+                  <a:pt x="50796" y="133338"/>
+                </a:lnTo>
+                <a:lnTo>
+                  <a:pt x="50796" y="71577"/>
+                </a:lnTo>
+                <a:lnTo>
+                  <a:pt x="101591" y="80466"/>
+                </a:lnTo>
+                <a:lnTo>
+                  <a:pt x="101591" y="133338"/>
+                </a:lnTo>
+                <a:cubicBezTo>
+                  <a:pt x="101591" y="198803"/>
+                  <a:pt x="162228" y="251861"/>
+                  <a:pt x="237046" y="251861"/>
+                </a:cubicBezTo>
+                <a:cubicBezTo>
+                  <a:pt x="311863" y="251861"/>
+                  <a:pt x="372500" y="198803"/>
+                  <a:pt x="372500" y="133338"/>
+                </a:cubicBezTo>
+                <a:lnTo>
+                  <a:pt x="372500" y="80466"/>
+                </a:lnTo>
+                <a:lnTo>
+                  <a:pt x="453667" y="66299"/>
+                </a:lnTo>
+                <a:cubicBezTo>
+                  <a:pt x="465519" y="64169"/>
+                  <a:pt x="474091" y="55002"/>
+                  <a:pt x="474091" y="44446"/>
+                </a:cubicBezTo>
+                <a:cubicBezTo>
+                  <a:pt x="474091" y="33890"/>
+                  <a:pt x="465519" y="24723"/>
+                  <a:pt x="453667" y="22686"/>
+                </a:cubicBezTo>
+                <a:lnTo>
+                  <a:pt x="255354" y="-12038"/>
+                </a:lnTo>
+                <a:close/>
+                <a:moveTo>
+                  <a:pt x="237046" y="207415"/>
+                </a:moveTo>
+                <a:cubicBezTo>
+                  <a:pt x="190271" y="207415"/>
+                  <a:pt x="152387" y="174266"/>
+                  <a:pt x="152387" y="133338"/>
+                </a:cubicBezTo>
+                <a:lnTo>
+                  <a:pt x="321704" y="133338"/>
+                </a:lnTo>
+                <a:cubicBezTo>
+                  <a:pt x="321704" y="174266"/>
+                  <a:pt x="283820" y="207415"/>
+                  <a:pt x="237046" y="207415"/>
+                </a:cubicBezTo>
+                <a:close/>
+                <a:moveTo>
+                  <a:pt x="127095" y="296399"/>
+                </a:moveTo>
+                <a:cubicBezTo>
+                  <a:pt x="62118" y="322511"/>
+                  <a:pt x="16931" y="379921"/>
+                  <a:pt x="16931" y="446590"/>
+                </a:cubicBezTo>
+                <a:cubicBezTo>
+                  <a:pt x="16931" y="461776"/>
+                  <a:pt x="31006" y="474091"/>
+                  <a:pt x="48361" y="474091"/>
+                </a:cubicBezTo>
+                <a:lnTo>
+                  <a:pt x="211648" y="474091"/>
+                </a:lnTo>
+                <a:lnTo>
+                  <a:pt x="211648" y="338902"/>
+                </a:lnTo>
+                <a:lnTo>
+                  <a:pt x="150905" y="299084"/>
+                </a:lnTo>
+                <a:cubicBezTo>
+                  <a:pt x="144026" y="294548"/>
+                  <a:pt x="134820" y="293344"/>
+                  <a:pt x="126988" y="296492"/>
+                </a:cubicBezTo>
+                <a:close/>
+                <a:moveTo>
+                  <a:pt x="262443" y="474091"/>
+                </a:moveTo>
+                <a:lnTo>
+                  <a:pt x="425730" y="474091"/>
+                </a:lnTo>
+                <a:cubicBezTo>
+                  <a:pt x="443085" y="474091"/>
+                  <a:pt x="457160" y="461776"/>
+                  <a:pt x="457160" y="446590"/>
+                </a:cubicBezTo>
+                <a:cubicBezTo>
+                  <a:pt x="457160" y="379921"/>
+                  <a:pt x="411973" y="322511"/>
+                  <a:pt x="346996" y="296492"/>
+                </a:cubicBezTo>
+                <a:cubicBezTo>
+                  <a:pt x="339165" y="293344"/>
+                  <a:pt x="329959" y="294548"/>
+                  <a:pt x="323081" y="299084"/>
+                </a:cubicBezTo>
+                <a:lnTo>
+                  <a:pt x="262338" y="338902"/>
+                </a:lnTo>
+                <a:lnTo>
+                  <a:pt x="262338" y="474091"/>
+                </a:lnTo>
+                <a:close/>
+              </a:path>
+            </a:pathLst>
+          </a:custGeom>
+          <a:solidFill>
+            <a:srgbClr val="1E2D3D"/>
+          </a:solidFill>
+          <a:ln/>
+        </p:spPr>
+        <p:txBody>
+          <a:bodyPr/>
+          <a:lstStyle/>
+          <a:p>
+            <a:endParaRPr lang="en-US" sz="1350"/>
+          </a:p>
+        </p:txBody>
+      </p:sp>
+      <p:sp>
+        <p:nvSpPr>
+          <p:cNvPr id="20" name="Shape 18"/>
+          <p:cNvSpPr/>
+          <p:nvPr/>
+        </p:nvSpPr>
+        <p:spPr>
+          <a:xfrm>
+            <a:off x="8951752" y="3391130"/>
+            <a:ext cx="5999578" cy="380926"/>
+          </a:xfrm>
+          <a:prstGeom prst="rect">
+            <a:avLst/>
+          </a:prstGeom>
+          <a:noFill/>
+          <a:ln/>
+        </p:spPr>
+        <p:txBody>
+          <a:bodyPr/>
+          <a:lstStyle/>
+          <a:p>
+            <a:endParaRPr lang="en-US" sz="1350"/>
+          </a:p>
+        </p:txBody>
+      </p:sp>
+      <p:sp>
+        <p:nvSpPr>
+          <p:cNvPr id="21" name="Text 19"/>
+          <p:cNvSpPr/>
+          <p:nvPr/>
+        </p:nvSpPr>
+        <p:spPr>
+          <a:xfrm>
+            <a:off x="8860329" y="3345419"/>
+            <a:ext cx="6186232" cy="472348"/>
+          </a:xfrm>
+          <a:prstGeom prst="rect">
+            <a:avLst/>
+          </a:prstGeom>
+          <a:noFill/>
+          <a:ln/>
+        </p:spPr>
+        <p:txBody>
+          <a:bodyPr wrap="none" lIns="0" tIns="0" rIns="0" bIns="0" rtlCol="0" anchor="t"/>
+          <a:lstStyle/>
+          <a:p>
+            <a:pPr algn="l">
+              <a:lnSpc>
+                <a:spcPct val="130000"/>
+              </a:lnSpc>
+            </a:pPr>
+            <a:r>
+              <a:rPr lang="en-US" dirty="0">
+                <a:solidFill>
+                  <a:srgbClr val="1E2D3D"/>
+                </a:solidFill>
+                <a:latin typeface="Liter" pitchFamily="34" charset="0"/>
+                <a:ea typeface="Liter" pitchFamily="34" charset="-122"/>
+                <a:cs typeface="Liter" pitchFamily="34" charset="-120"/>
+              </a:rPr>
+              <a:t>Campus &amp; Talent Focus</a:t>
+            </a:r>
+            <a:endParaRPr lang="en-US" dirty="0"/>
+          </a:p>
+        </p:txBody>
+      </p:sp>
+      <p:sp>
+        <p:nvSpPr>
+          <p:cNvPr id="22" name="Shape 20"/>
+          <p:cNvSpPr/>
+          <p:nvPr/>
+        </p:nvSpPr>
+        <p:spPr>
+          <a:xfrm>
+            <a:off x="8494641" y="3905380"/>
+            <a:ext cx="6666198" cy="4190182"/>
+          </a:xfrm>
+          <a:prstGeom prst="rect">
+            <a:avLst/>
+          </a:prstGeom>
+          <a:noFill/>
+          <a:ln/>
+        </p:spPr>
+        <p:txBody>
+          <a:bodyPr/>
+          <a:lstStyle/>
+          <a:p>
+            <a:endParaRPr lang="en-US" sz="1350"/>
+          </a:p>
+        </p:txBody>
+      </p:sp>
+      <p:sp>
+        <p:nvSpPr>
+          <p:cNvPr id="23" name="Text 21"/>
+          <p:cNvSpPr/>
+          <p:nvPr/>
+        </p:nvSpPr>
+        <p:spPr>
+          <a:xfrm>
+            <a:off x="8403219" y="3859669"/>
+            <a:ext cx="6851614" cy="4281604"/>
+          </a:xfrm>
+          <a:prstGeom prst="rect">
+            <a:avLst/>
+          </a:prstGeom>
+          <a:noFill/>
+          <a:ln/>
+        </p:spPr>
+        <p:txBody>
+          <a:bodyPr wrap="square" lIns="0" tIns="0" rIns="0" bIns="0" rtlCol="0" anchor="t"/>
+          <a:lstStyle/>
+          <a:p>
+            <a:pPr algn="l">
+              <a:lnSpc>
+                <a:spcPct val="170000"/>
+              </a:lnSpc>
+            </a:pPr>
+            <a:r>
+              <a:rPr lang="en-US" sz="1500" dirty="0">
+                <a:solidFill>
+                  <a:srgbClr val="1E2D3D"/>
+                </a:solidFill>
+                <a:latin typeface="Quattrocento Sans" pitchFamily="34" charset="0"/>
+                <a:ea typeface="Quattrocento Sans" pitchFamily="34" charset="-122"/>
+                <a:cs typeface="Quattrocento Sans" pitchFamily="34" charset="-120"/>
+              </a:rPr>
+              <a:t>Designed and executed </a:t>
+            </a:r>
+            <a:r>
+              <a:rPr lang="en-US" sz="1500" b="1" dirty="0">
+                <a:solidFill>
+                  <a:srgbClr val="1E2D3D"/>
+                </a:solidFill>
+                <a:latin typeface="Quattrocento Sans" pitchFamily="34" charset="0"/>
+                <a:ea typeface="Quattrocento Sans" pitchFamily="34" charset="-122"/>
+                <a:cs typeface="Quattrocento Sans" pitchFamily="34" charset="-120"/>
+              </a:rPr>
+              <a:t>campus hiring and internship engagement programs</a:t>
+            </a:r>
+            <a:r>
+              <a:rPr lang="en-US" sz="1500" dirty="0">
+                <a:solidFill>
+                  <a:srgbClr val="1E2D3D"/>
+                </a:solidFill>
+                <a:latin typeface="Quattrocento Sans" pitchFamily="34" charset="0"/>
+                <a:ea typeface="Quattrocento Sans" pitchFamily="34" charset="-122"/>
+                <a:cs typeface="Quattrocento Sans" pitchFamily="34" charset="-120"/>
+              </a:rPr>
+              <a:t>, collaborating with colleges to identify, recruit, and develop early-career talent.</a:t>
+            </a:r>
+            <a:endParaRPr lang="en-US" sz="1500" dirty="0"/>
+          </a:p>
+          <a:p>
+            <a:pPr algn="l">
+              <a:lnSpc>
+                <a:spcPct val="170000"/>
+              </a:lnSpc>
+            </a:pPr>
+            <a:r>
+              <a:rPr lang="en-US" sz="1500" dirty="0">
+                <a:solidFill>
+                  <a:srgbClr val="1E2D3D"/>
+                </a:solidFill>
+                <a:latin typeface="Quattrocento Sans" pitchFamily="34" charset="0"/>
+                <a:ea typeface="Quattrocento Sans" pitchFamily="34" charset="-122"/>
+                <a:cs typeface="Quattrocento Sans" pitchFamily="34" charset="-120"/>
+              </a:rPr>
+              <a:t>Extensive experience in </a:t>
+            </a:r>
+            <a:r>
+              <a:rPr lang="en-US" sz="1500" b="1" dirty="0">
+                <a:solidFill>
+                  <a:srgbClr val="1E2D3D"/>
+                </a:solidFill>
+                <a:latin typeface="Quattrocento Sans" pitchFamily="34" charset="0"/>
+                <a:ea typeface="Quattrocento Sans" pitchFamily="34" charset="-122"/>
+                <a:cs typeface="Quattrocento Sans" pitchFamily="34" charset="-120"/>
+              </a:rPr>
+              <a:t>internship programs, campus hiring, and industry-academia engagement</a:t>
+            </a:r>
+            <a:r>
+              <a:rPr lang="en-US" sz="1500" dirty="0">
+                <a:solidFill>
+                  <a:srgbClr val="1E2D3D"/>
+                </a:solidFill>
+                <a:latin typeface="Quattrocento Sans" pitchFamily="34" charset="0"/>
+                <a:ea typeface="Quattrocento Sans" pitchFamily="34" charset="-122"/>
+                <a:cs typeface="Quattrocento Sans" pitchFamily="34" charset="-120"/>
+              </a:rPr>
+              <a:t>.</a:t>
+            </a:r>
+            <a:endParaRPr lang="en-US" sz="1500" dirty="0"/>
+          </a:p>
+          <a:p>
+            <a:pPr algn="l">
+              <a:lnSpc>
+                <a:spcPct val="170000"/>
+              </a:lnSpc>
+            </a:pPr>
+            <a:r>
+              <a:rPr lang="en-US" sz="1500" dirty="0">
+                <a:solidFill>
+                  <a:srgbClr val="1E2D3D"/>
+                </a:solidFill>
+                <a:latin typeface="Quattrocento Sans" pitchFamily="34" charset="0"/>
+                <a:ea typeface="Quattrocento Sans" pitchFamily="34" charset="-122"/>
+                <a:cs typeface="Quattrocento Sans" pitchFamily="34" charset="-120"/>
+              </a:rPr>
+              <a:t>Strong focus on </a:t>
+            </a:r>
+            <a:r>
+              <a:rPr lang="en-US" sz="1500" b="1" dirty="0">
+                <a:solidFill>
+                  <a:srgbClr val="1E2D3D"/>
+                </a:solidFill>
+                <a:latin typeface="Quattrocento Sans" pitchFamily="34" charset="0"/>
+                <a:ea typeface="Quattrocento Sans" pitchFamily="34" charset="-122"/>
+                <a:cs typeface="Quattrocento Sans" pitchFamily="34" charset="-120"/>
+              </a:rPr>
+              <a:t>employee development, performance management, and leadership coaching</a:t>
+            </a:r>
+            <a:r>
+              <a:rPr lang="en-US" sz="1500" dirty="0">
+                <a:solidFill>
+                  <a:srgbClr val="1E2D3D"/>
+                </a:solidFill>
+                <a:latin typeface="Quattrocento Sans" pitchFamily="34" charset="0"/>
+                <a:ea typeface="Quattrocento Sans" pitchFamily="34" charset="-122"/>
+                <a:cs typeface="Quattrocento Sans" pitchFamily="34" charset="-120"/>
+              </a:rPr>
+              <a:t>.</a:t>
+            </a:r>
+            <a:endParaRPr lang="en-US" sz="1500" dirty="0"/>
+          </a:p>
+          <a:p>
+            <a:pPr algn="l">
+              <a:lnSpc>
+                <a:spcPct val="170000"/>
+              </a:lnSpc>
+            </a:pPr>
+            <a:r>
+              <a:rPr lang="en-US" sz="1500" dirty="0">
+                <a:solidFill>
+                  <a:srgbClr val="1E2D3D"/>
+                </a:solidFill>
+                <a:latin typeface="Quattrocento Sans" pitchFamily="34" charset="0"/>
+                <a:ea typeface="Quattrocento Sans" pitchFamily="34" charset="-122"/>
+                <a:cs typeface="Quattrocento Sans" pitchFamily="34" charset="-120"/>
+              </a:rPr>
+              <a:t>Combines </a:t>
+            </a:r>
+            <a:r>
+              <a:rPr lang="en-US" sz="1500" b="1" dirty="0">
+                <a:solidFill>
+                  <a:srgbClr val="1E2D3D"/>
+                </a:solidFill>
+                <a:latin typeface="Quattrocento Sans" pitchFamily="34" charset="0"/>
+                <a:ea typeface="Quattrocento Sans" pitchFamily="34" charset="-122"/>
+                <a:cs typeface="Quattrocento Sans" pitchFamily="34" charset="-120"/>
+              </a:rPr>
+              <a:t>people leadership, project delivery, and product management</a:t>
+            </a:r>
+            <a:r>
+              <a:rPr lang="en-US" sz="1500" dirty="0">
+                <a:solidFill>
+                  <a:srgbClr val="1E2D3D"/>
+                </a:solidFill>
+                <a:latin typeface="Quattrocento Sans" pitchFamily="34" charset="0"/>
+                <a:ea typeface="Quattrocento Sans" pitchFamily="34" charset="-122"/>
+                <a:cs typeface="Quattrocento Sans" pitchFamily="34" charset="-120"/>
+              </a:rPr>
+              <a:t> expertise to drive organizational growth.</a:t>
+            </a:r>
+            <a:endParaRPr lang="en-US" sz="1500" dirty="0"/>
+          </a:p>
+        </p:txBody>
+      </p:sp>
+      <p:sp>
+        <p:nvSpPr>
+          <p:cNvPr id="24" name="Shape 22"/>
+          <p:cNvSpPr/>
+          <p:nvPr/>
+        </p:nvSpPr>
+        <p:spPr>
+          <a:xfrm>
+            <a:off x="761852" y="8635238"/>
+            <a:ext cx="14729155" cy="25427"/>
+          </a:xfrm>
+          <a:prstGeom prst="rect">
+            <a:avLst/>
+          </a:prstGeom>
+          <a:solidFill>
+            <a:srgbClr val="C4956A"/>
+          </a:solidFill>
+          <a:ln/>
+        </p:spPr>
+        <p:txBody>
+          <a:bodyPr/>
+          <a:lstStyle/>
+          <a:p>
+            <a:endParaRPr lang="en-US" sz="1350"/>
+          </a:p>
+        </p:txBody>
+      </p:sp>
+      <p:sp>
+        <p:nvSpPr>
+          <p:cNvPr id="25" name="Shape 23"/>
+          <p:cNvSpPr/>
+          <p:nvPr/>
+        </p:nvSpPr>
+        <p:spPr>
+          <a:xfrm>
+            <a:off x="13459340" y="8736755"/>
+            <a:ext cx="2031571" cy="253982"/>
+          </a:xfrm>
+          <a:prstGeom prst="rect">
+            <a:avLst/>
+          </a:prstGeom>
+          <a:noFill/>
+          <a:ln/>
+        </p:spPr>
+        <p:txBody>
+          <a:bodyPr/>
+          <a:lstStyle/>
+          <a:p>
+            <a:endParaRPr lang="en-US" sz="1350"/>
+          </a:p>
+        </p:txBody>
+      </p:sp>
+      <p:sp>
+        <p:nvSpPr>
+          <p:cNvPr id="26" name="Text 24"/>
+          <p:cNvSpPr/>
+          <p:nvPr/>
+        </p:nvSpPr>
+        <p:spPr>
+          <a:xfrm>
+            <a:off x="13367918" y="8691044"/>
+            <a:ext cx="2214416" cy="345404"/>
+          </a:xfrm>
+          <a:prstGeom prst="rect">
+            <a:avLst/>
+          </a:prstGeom>
+          <a:noFill/>
+          <a:ln/>
+        </p:spPr>
+        <p:txBody>
+          <a:bodyPr wrap="none" lIns="0" tIns="0" rIns="0" bIns="0" rtlCol="0" anchor="ctr"/>
+          <a:lstStyle/>
+          <a:p>
+            <a:pPr algn="r">
+              <a:lnSpc>
+                <a:spcPct val="130000"/>
+              </a:lnSpc>
+            </a:pPr>
+            <a:r>
+              <a:rPr lang="en-US" sz="1297" kern="0" spc="200" dirty="0">
+                <a:solidFill>
+                  <a:srgbClr val="6B7B8D"/>
+                </a:solidFill>
+                <a:latin typeface="Liter" pitchFamily="34" charset="0"/>
+                <a:ea typeface="Liter" pitchFamily="34" charset="-122"/>
+                <a:cs typeface="Liter" pitchFamily="34" charset="-120"/>
+              </a:rPr>
+              <a:t>PLACEMENTHUB</a:t>
+            </a:r>
+            <a:endParaRPr lang="en-US" sz="1297" dirty="0"/>
           </a:p>
         </p:txBody>
       </p:sp>

</xml_diff>